<commit_message>
updating user manual for vecto 3 gui
</commit_message>
<xml_diff>
--- a/Documentation/User Manual Source/UserGuide VECTO3 GUI.pptx
+++ b/Documentation/User Manual Source/UserGuide VECTO3 GUI.pptx
@@ -4566,9 +4566,22 @@
               </a:tabLst>
             </a:pPr>
             <a:r>
-              <a:rPr lang="en-US" sz="1400" dirty="0" smtClean="0"/>
-              <a:t>The new graphical user interface “VECTO 3” currently allows only creating and editing bus-related job files and component data. This is: completed bus XML, completed bus job file, single bus job file. Support for further VECTO Job data and component data is planned for the future.</a:t>
-            </a:r>
+              <a:rPr lang="en-US" sz="1400" b="1" dirty="0"/>
+              <a:t>This is a first version to evaluate a new, more </a:t>
+            </a:r>
+            <a:r>
+              <a:rPr lang="en-US" sz="1400" b="1" dirty="0" smtClean="0"/>
+              <a:t>flexible and better structured </a:t>
+            </a:r>
+            <a:r>
+              <a:rPr lang="en-US" sz="1400" b="1" dirty="0"/>
+              <a:t>graphical user interface</a:t>
+            </a:r>
+            <a:r>
+              <a:rPr lang="en-US" sz="1400" b="1" dirty="0" smtClean="0"/>
+              <a:t>. </a:t>
+            </a:r>
+            <a:endParaRPr lang="en-US" sz="1400" b="1" dirty="0"/>
           </a:p>
           <a:p>
             <a:pPr lvl="1">
@@ -4578,7 +4591,7 @@
             </a:pPr>
             <a:r>
               <a:rPr lang="en-US" sz="1400" dirty="0" smtClean="0"/>
-              <a:t>This GUI allows to simulate existing VECTO jobs (heavy lorries, medium lorries, engine only, …)</a:t>
+              <a:t>The new graphical user interface “VECTO 3” currently allows only creating and editing bus-related job files and component data. This is: completed bus XML, completed bus job file, single bus job file. Support for further VECTO Job data and component data is planned for the future.</a:t>
             </a:r>
           </a:p>
           <a:p>
@@ -4589,7 +4602,7 @@
             </a:pPr>
             <a:r>
               <a:rPr lang="en-US" sz="1400" dirty="0" smtClean="0"/>
-              <a:t>This is a first version to evaluate a new, more flexible graphical user interface.</a:t>
+              <a:t>This GUI allows to simulate existing VECTO jobs (heavy lorries, medium lorries, engine only, …)</a:t>
             </a:r>
           </a:p>
           <a:p>
@@ -4601,6 +4614,17 @@
             <a:r>
               <a:rPr lang="en-US" sz="1400" dirty="0" smtClean="0"/>
               <a:t>The functionality of the new graphical user interface is similar to the currently official VECTO version</a:t>
+            </a:r>
+          </a:p>
+          <a:p>
+            <a:pPr lvl="1">
+              <a:tabLst>
+                <a:tab pos="1885950" algn="l"/>
+              </a:tabLst>
+            </a:pPr>
+            <a:r>
+              <a:rPr lang="en-US" sz="1400" dirty="0" smtClean="0"/>
+              <a:t>This draft version is intended to be used in the 2020 pilot phases. Features of final / long-term version to be discussed with Commission and stakeholders after feedback.</a:t>
             </a:r>
             <a:endParaRPr lang="en-US" sz="1400" dirty="0"/>
           </a:p>
@@ -4874,8 +4898,8 @@
         </p:nvCxnSpPr>
         <p:spPr bwMode="auto">
           <a:xfrm flipV="1">
-            <a:off x="5004048" y="1700808"/>
-            <a:ext cx="1080120" cy="1152128"/>
+            <a:off x="5004048" y="2553722"/>
+            <a:ext cx="1224136" cy="299214"/>
           </a:xfrm>
           <a:prstGeom prst="line">
             <a:avLst/>
@@ -4914,7 +4938,7 @@
         </p:nvSpPr>
         <p:spPr>
           <a:xfrm>
-            <a:off x="6300192" y="1395413"/>
+            <a:off x="6300192" y="2303338"/>
             <a:ext cx="2592288" cy="877163"/>
           </a:xfrm>
           <a:prstGeom prst="rect">
@@ -5212,17 +5236,19 @@
       <p:cxnSp>
         <p:nvCxnSpPr>
           <p:cNvPr id="28" name="Gewinkelter Verbinder 27"/>
-          <p:cNvCxnSpPr/>
+          <p:cNvCxnSpPr>
+            <a:endCxn id="33" idx="1"/>
+          </p:cNvCxnSpPr>
           <p:nvPr/>
         </p:nvCxnSpPr>
         <p:spPr bwMode="auto">
           <a:xfrm flipV="1">
-            <a:off x="683568" y="2482927"/>
-            <a:ext cx="5458328" cy="398629"/>
+            <a:off x="683568" y="1881953"/>
+            <a:ext cx="5616624" cy="999604"/>
           </a:xfrm>
           <a:prstGeom prst="bentConnector3">
             <a:avLst>
-              <a:gd name="adj1" fmla="val -111"/>
+              <a:gd name="adj1" fmla="val -197"/>
             </a:avLst>
           </a:prstGeom>
           <a:solidFill>
@@ -5259,7 +5285,7 @@
         </p:nvSpPr>
         <p:spPr>
           <a:xfrm>
-            <a:off x="6334473" y="2389403"/>
+            <a:off x="6300192" y="1666509"/>
             <a:ext cx="2592288" cy="430887"/>
           </a:xfrm>
           <a:prstGeom prst="rect">
@@ -6027,6 +6053,206 @@
             <a:r>
               <a:rPr lang="en-US" sz="1100" b="0" dirty="0" smtClean="0"/>
               <a:t>A separate tab is provided for every component (see screenshots on the following slides)</a:t>
+            </a:r>
+            <a:endParaRPr lang="de-AT" sz="1100" b="0" dirty="0" err="1" smtClean="0"/>
+          </a:p>
+        </p:txBody>
+      </p:sp>
+      <p:cxnSp>
+        <p:nvCxnSpPr>
+          <p:cNvPr id="6" name="Gerader Verbinder 5"/>
+          <p:cNvCxnSpPr/>
+          <p:nvPr/>
+        </p:nvCxnSpPr>
+        <p:spPr bwMode="auto">
+          <a:xfrm flipV="1">
+            <a:off x="4860032" y="5661248"/>
+            <a:ext cx="576064" cy="325343"/>
+          </a:xfrm>
+          <a:prstGeom prst="line">
+            <a:avLst/>
+          </a:prstGeom>
+          <a:solidFill>
+            <a:schemeClr val="accent1"/>
+          </a:solidFill>
+          <a:ln w="22225" cap="flat" cmpd="sng" algn="ctr">
+            <a:solidFill>
+              <a:srgbClr val="FF0000"/>
+            </a:solidFill>
+            <a:prstDash val="solid"/>
+            <a:round/>
+            <a:headEnd type="none" w="med" len="med"/>
+            <a:tailEnd type="none" w="med" len="med"/>
+          </a:ln>
+          <a:effectLst/>
+          <a:extLst>
+            <a:ext uri="{AF507438-7753-43E0-B8FC-AC1667EBCBE1}">
+              <a14:hiddenEffects xmlns:a14="http://schemas.microsoft.com/office/drawing/2010/main">
+                <a:effectLst>
+                  <a:outerShdw dist="35921" dir="2700000" algn="ctr" rotWithShape="0">
+                    <a:schemeClr val="bg2"/>
+                  </a:outerShdw>
+                </a:effectLst>
+              </a14:hiddenEffects>
+            </a:ext>
+          </a:extLst>
+        </p:spPr>
+      </p:cxnSp>
+      <p:sp>
+        <p:nvSpPr>
+          <p:cNvPr id="7" name="Textfeld 6"/>
+          <p:cNvSpPr txBox="1"/>
+          <p:nvPr/>
+        </p:nvSpPr>
+        <p:spPr>
+          <a:xfrm>
+            <a:off x="5364088" y="5517232"/>
+            <a:ext cx="2592288" cy="938719"/>
+          </a:xfrm>
+          <a:prstGeom prst="rect">
+            <a:avLst/>
+          </a:prstGeom>
+          <a:noFill/>
+          <a:ln>
+            <a:noFill/>
+          </a:ln>
+        </p:spPr>
+        <p:txBody>
+          <a:bodyPr wrap="square" rtlCol="0">
+            <a:spAutoFit/>
+          </a:bodyPr>
+          <a:lstStyle/>
+          <a:p>
+            <a:pPr algn="l">
+              <a:spcBef>
+                <a:spcPts val="0"/>
+              </a:spcBef>
+            </a:pPr>
+            <a:r>
+              <a:rPr lang="en-US" sz="1100" b="0" dirty="0" smtClean="0"/>
+              <a:t>Store changes to the current component VECTO internally (changes are NOT saved to the file). Future changes can be undone with the ‘Reset’ button</a:t>
+            </a:r>
+            <a:endParaRPr lang="de-AT" sz="1100" b="0" dirty="0" err="1" smtClean="0"/>
+          </a:p>
+        </p:txBody>
+      </p:sp>
+      <p:cxnSp>
+        <p:nvCxnSpPr>
+          <p:cNvPr id="11" name="Gewinkelter Verbinder 10"/>
+          <p:cNvCxnSpPr/>
+          <p:nvPr/>
+        </p:nvCxnSpPr>
+        <p:spPr bwMode="auto">
+          <a:xfrm>
+            <a:off x="1115616" y="6021288"/>
+            <a:ext cx="4320480" cy="288032"/>
+          </a:xfrm>
+          <a:prstGeom prst="bentConnector3">
+            <a:avLst>
+              <a:gd name="adj1" fmla="val 29"/>
+            </a:avLst>
+          </a:prstGeom>
+          <a:solidFill>
+            <a:schemeClr val="accent1"/>
+          </a:solidFill>
+          <a:ln w="22225" cap="flat" cmpd="sng" algn="ctr">
+            <a:solidFill>
+              <a:srgbClr val="FF0000"/>
+            </a:solidFill>
+            <a:prstDash val="solid"/>
+            <a:round/>
+            <a:headEnd type="none" w="med" len="med"/>
+            <a:tailEnd type="none" w="med" len="med"/>
+          </a:ln>
+          <a:effectLst/>
+          <a:extLst>
+            <a:ext uri="{AF507438-7753-43E0-B8FC-AC1667EBCBE1}">
+              <a14:hiddenEffects xmlns:a14="http://schemas.microsoft.com/office/drawing/2010/main">
+                <a:effectLst>
+                  <a:outerShdw dist="35921" dir="2700000" algn="ctr" rotWithShape="0">
+                    <a:schemeClr val="bg2"/>
+                  </a:outerShdw>
+                </a:effectLst>
+              </a14:hiddenEffects>
+            </a:ext>
+          </a:extLst>
+        </p:spPr>
+      </p:cxnSp>
+      <p:cxnSp>
+        <p:nvCxnSpPr>
+          <p:cNvPr id="16" name="Gerader Verbinder 15"/>
+          <p:cNvCxnSpPr>
+            <a:endCxn id="17" idx="1"/>
+          </p:cNvCxnSpPr>
+          <p:nvPr/>
+        </p:nvCxnSpPr>
+        <p:spPr bwMode="auto">
+          <a:xfrm flipV="1">
+            <a:off x="3851920" y="5263463"/>
+            <a:ext cx="1512168" cy="668076"/>
+          </a:xfrm>
+          <a:prstGeom prst="line">
+            <a:avLst/>
+          </a:prstGeom>
+          <a:solidFill>
+            <a:schemeClr val="accent1"/>
+          </a:solidFill>
+          <a:ln w="22225" cap="flat" cmpd="sng" algn="ctr">
+            <a:solidFill>
+              <a:srgbClr val="FF0000"/>
+            </a:solidFill>
+            <a:prstDash val="solid"/>
+            <a:round/>
+            <a:headEnd type="none" w="med" len="med"/>
+            <a:tailEnd type="none" w="med" len="med"/>
+          </a:ln>
+          <a:effectLst/>
+          <a:extLst>
+            <a:ext uri="{AF507438-7753-43E0-B8FC-AC1667EBCBE1}">
+              <a14:hiddenEffects xmlns:a14="http://schemas.microsoft.com/office/drawing/2010/main">
+                <a:effectLst>
+                  <a:outerShdw dist="35921" dir="2700000" algn="ctr" rotWithShape="0">
+                    <a:schemeClr val="bg2"/>
+                  </a:outerShdw>
+                </a:effectLst>
+              </a14:hiddenEffects>
+            </a:ext>
+          </a:extLst>
+        </p:spPr>
+      </p:cxnSp>
+      <p:sp>
+        <p:nvSpPr>
+          <p:cNvPr id="17" name="Textfeld 16"/>
+          <p:cNvSpPr txBox="1"/>
+          <p:nvPr/>
+        </p:nvSpPr>
+        <p:spPr>
+          <a:xfrm>
+            <a:off x="5364088" y="5132658"/>
+            <a:ext cx="2592288" cy="261610"/>
+          </a:xfrm>
+          <a:prstGeom prst="rect">
+            <a:avLst/>
+          </a:prstGeom>
+          <a:noFill/>
+          <a:ln>
+            <a:noFill/>
+          </a:ln>
+        </p:spPr>
+        <p:txBody>
+          <a:bodyPr wrap="square" rtlCol="0">
+            <a:spAutoFit/>
+          </a:bodyPr>
+          <a:lstStyle/>
+          <a:p>
+            <a:pPr algn="l">
+              <a:spcBef>
+                <a:spcPts val="0"/>
+              </a:spcBef>
+            </a:pPr>
+            <a:r>
+              <a:rPr lang="en-US" sz="1100" b="0" dirty="0" smtClean="0"/>
+              <a:t>Save changes to the file</a:t>
             </a:r>
             <a:endParaRPr lang="de-AT" sz="1100" b="0" dirty="0" err="1" smtClean="0"/>
           </a:p>

</xml_diff>